<commit_message>
feat: chatbot-DB integration, workshop guide, updated slides
- search_all_news tool: keyword search across all cached articles
- search_robotics_news wired into chat agent (shared DB pattern)
- Expanded system prompt: agent picks right tool per query type
- db.py: search_articles() full-text LIKE search method
- Workshop guide (WORKSHOP_NEWS_DIGEST.md): step-by-step participant guide
  with shared DB explanation, pre-scrape vs live-fetch comparison,
  Future Work / RAG section, aitmpl.com exploration step
- Updated slides: shared DB architecture, 54 tests badge, Step 8 CONNECT card
- README.md removed (replaced by WORKSHOP_NEWS_DIGEST.md)
- 54 passing tests

Co-Authored-By: Claude Sonnet 4.6 <noreply@anthropic.com>
</commit_message>
<xml_diff>
--- a/Claude_Code_Workshop.pptx
+++ b/Claude_Code_Workshop.pptx
@@ -3822,83 +3822,84 @@
           </a:bodyPr>
           <a:lstStyle/>
           <a:p>
-            <a:pPr>
+            <a:pPr algn="l">
               <a:spcBef>
                 <a:spcPts val="400"/>
               </a:spcBef>
             </a:pPr>
             <a:r>
-              <a:rPr sz="1300">
+              <a:rPr b="0" sz="1300">
                 <a:solidFill>
                   <a:srgbClr val="C9D1D9"/>
                 </a:solidFill>
-                <a:latin typeface="Calibri"/>
-              </a:rPr>
-              <a:t>•  Chat interface → Claude agent → RSS feeds → SQLite cache</a:t>
-            </a:r>
-          </a:p>
-          <a:p>
-            <a:pPr>
-              <a:spcBef>
-                <a:spcPts val="400"/>
-              </a:spcBef>
-            </a:pPr>
-            <a:r>
-              <a:rPr sz="1300">
+              </a:rPr>
+              <a:t>•  Chat interface → Claude agent → reads from shared SQLite DB</a:t>
+            </a:r>
+          </a:p>
+          <a:p>
+            <a:pPr algn="l"/>
+            <a:r>
+              <a:rPr b="0" sz="1300">
                 <a:solidFill>
                   <a:srgbClr val="C9D1D9"/>
                 </a:solidFill>
-                <a:latin typeface="Calibri"/>
-              </a:rPr>
-              <a:t>•  Dual AI provider: AWS Bedrock OR Anthropic API key</a:t>
-            </a:r>
-          </a:p>
-          <a:p>
-            <a:pPr>
-              <a:spcBef>
-                <a:spcPts val="400"/>
-              </a:spcBef>
-            </a:pPr>
-            <a:r>
-              <a:rPr sz="1300">
+              </a:rPr>
+              <a:t>•  Pages scrape specialist RSS feeds every 60s → populate DB</a:t>
+            </a:r>
+          </a:p>
+          <a:p>
+            <a:pPr algn="l"/>
+            <a:r>
+              <a:rPr b="0" sz="1300">
                 <a:solidFill>
                   <a:srgbClr val="C9D1D9"/>
                 </a:solidFill>
-                <a:latin typeface="Calibri"/>
-              </a:rPr>
-              <a:t>•  Robotics page with 5 sub-topic filters</a:t>
-            </a:r>
-          </a:p>
-          <a:p>
-            <a:pPr>
-              <a:spcBef>
-                <a:spcPts val="400"/>
-              </a:spcBef>
-            </a:pPr>
-            <a:r>
-              <a:rPr sz="1300">
+              </a:rPr>
+              <a:t>•  Chatbot queries DB first (fast) → fetches live only if empty</a:t>
+            </a:r>
+          </a:p>
+          <a:p>
+            <a:pPr algn="l"/>
+            <a:r>
+              <a:rPr b="0" sz="1300">
                 <a:solidFill>
                   <a:srgbClr val="C9D1D9"/>
                 </a:solidFill>
-                <a:latin typeface="Calibri"/>
+              </a:rPr>
+              <a:t>•  Two new tools: search_all_news (cross-topic) + search_robotics_news</a:t>
+            </a:r>
+          </a:p>
+          <a:p>
+            <a:pPr algn="l"/>
+            <a:r>
+              <a:rPr b="0" sz="1300">
+                <a:solidFill>
+                  <a:srgbClr val="C9D1D9"/>
+                </a:solidFill>
+              </a:rPr>
+              <a:t>•  Dual AI provider: AWS Bedrock or Anthropic API key</a:t>
+            </a:r>
+          </a:p>
+          <a:p>
+            <a:pPr algn="l"/>
+            <a:r>
+              <a:rPr b="0" sz="1300">
+                <a:solidFill>
+                  <a:srgbClr val="C9D1D9"/>
+                </a:solidFill>
               </a:rPr>
               <a:t>•  Streaming responses via SSE</a:t>
             </a:r>
           </a:p>
           <a:p>
-            <a:pPr>
-              <a:spcBef>
-                <a:spcPts val="400"/>
-              </a:spcBef>
-            </a:pPr>
-            <a:r>
-              <a:rPr sz="1300">
+            <a:pPr algn="l"/>
+            <a:r>
+              <a:rPr b="0" sz="1300">
                 <a:solidFill>
                   <a:srgbClr val="C9D1D9"/>
                 </a:solidFill>
-                <a:latin typeface="Calibri"/>
-              </a:rPr>
-              <a:t>•  53 passing tests</a:t>
+              </a:rPr>
+              <a:t>•  54 passing tests</a:t>
             </a:r>
           </a:p>
         </p:txBody>
@@ -3946,13 +3947,53 @@
           <a:p>
             <a:pPr algn="ctr"/>
             <a:r>
-              <a:rPr sz="1400" b="1">
+              <a:rPr b="1" sz="1400">
                 <a:solidFill>
                   <a:srgbClr val="2DD4BF"/>
                 </a:solidFill>
-                <a:latin typeface="Calibri"/>
-              </a:rPr>
-              <a:t>53 Tests Passing</a:t>
+              </a:rPr>
+              <a:t>54 Tests Passing</a:t>
+            </a:r>
+          </a:p>
+        </p:txBody>
+      </p:sp>
+      <p:sp>
+        <p:nvSpPr>
+          <p:cNvPr id="10" name="TextBox 9"/>
+          <p:cNvSpPr txBox="1"/>
+          <p:nvPr/>
+        </p:nvSpPr>
+        <p:spPr>
+          <a:xfrm>
+            <a:off x="502920" y="5900000"/>
+            <a:ext cx="11183112" cy="500000"/>
+          </a:xfrm>
+          <a:prstGeom prst="rect">
+            <a:avLst/>
+          </a:prstGeom>
+          <a:solidFill>
+            <a:srgbClr val="E97B3C"/>
+          </a:solidFill>
+          <a:ln>
+            <a:solidFill>
+              <a:srgbClr val="E97B3C"/>
+            </a:solidFill>
+          </a:ln>
+        </p:spPr>
+        <p:txBody>
+          <a:bodyPr wrap="square" tIns="101600" bIns="101600" lIns="152400" rIns="152400">
+            <a:spAutoFit/>
+          </a:bodyPr>
+          <a:lstStyle/>
+          <a:p>
+            <a:pPr algn="ctr"/>
+            <a:r>
+              <a:rPr b="1" sz="1400">
+                <a:solidFill>
+                  <a:srgbClr val="FFFFFF"/>
+                </a:solidFill>
+              </a:rPr>
+              <a:t>One DB, two interfaces — pages scrape it, chatbot reads from it</a:t>
             </a:r>
           </a:p>
         </p:txBody>
@@ -4946,6 +4987,121 @@
                 <a:latin typeface="Calibri"/>
               </a:rPr>
               <a:t>/save-to-claude-md → decisions appended to CLAUDE.md</a:t>
+            </a:r>
+          </a:p>
+        </p:txBody>
+      </p:sp>
+      <p:sp>
+        <p:nvSpPr>
+          <p:cNvPr id="26" name="Rectangle 25"/>
+          <p:cNvSpPr/>
+          <p:nvPr/>
+        </p:nvSpPr>
+        <p:spPr>
+          <a:xfrm>
+            <a:off x="502920" y="5640680"/>
+            <a:ext cx="1480021" cy="4297680"/>
+          </a:xfrm>
+          <a:prstGeom prst="roundRect">
+            <a:avLst>
+              <a:gd name="adj" fmla="val 16667"/>
+            </a:avLst>
+          </a:prstGeom>
+          <a:solidFill>
+            <a:srgbClr val="131C2A"/>
+          </a:solidFill>
+          <a:ln w="19050">
+            <a:solidFill>
+              <a:srgbClr val="2DD4BF"/>
+            </a:solidFill>
+          </a:ln>
+        </p:spPr>
+        <p:style>
+          <a:lnRef idx="1">
+            <a:schemeClr val="accent1"/>
+          </a:lnRef>
+          <a:fillRef idx="3">
+            <a:schemeClr val="accent1"/>
+          </a:fillRef>
+          <a:effectRef idx="2">
+            <a:schemeClr val="accent1"/>
+          </a:effectRef>
+          <a:fontRef idx="minor">
+            <a:schemeClr val="lt1"/>
+          </a:fontRef>
+        </p:style>
+        <p:txBody>
+          <a:bodyPr rtlCol="0" anchor="ctr"/>
+          <a:lstStyle/>
+          <a:p>
+            <a:pPr algn="ctr"/>
+          </a:p>
+        </p:txBody>
+      </p:sp>
+      <p:sp>
+        <p:nvSpPr>
+          <p:cNvPr id="27" name="TextBox 26"/>
+          <p:cNvSpPr txBox="1"/>
+          <p:nvPr/>
+        </p:nvSpPr>
+        <p:spPr>
+          <a:xfrm>
+            <a:off x="548640" y="5732120"/>
+            <a:ext cx="1388581" cy="685800"/>
+          </a:xfrm>
+          <a:prstGeom prst="rect">
+            <a:avLst/>
+          </a:prstGeom>
+          <a:noFill/>
+        </p:spPr>
+        <p:txBody>
+          <a:bodyPr wrap="none">
+            <a:spAutoFit/>
+          </a:bodyPr>
+          <a:lstStyle/>
+          <a:p>
+            <a:pPr algn="ctr"/>
+            <a:r>
+              <a:rPr b="1" sz="1000">
+                <a:solidFill>
+                  <a:srgbClr val="2DD4BF"/>
+                </a:solidFill>
+              </a:rPr>
+              <a:t>8. CONNECT</a:t>
+            </a:r>
+          </a:p>
+        </p:txBody>
+      </p:sp>
+      <p:sp>
+        <p:nvSpPr>
+          <p:cNvPr id="28" name="TextBox 27"/>
+          <p:cNvSpPr txBox="1"/>
+          <p:nvPr/>
+        </p:nvSpPr>
+        <p:spPr>
+          <a:xfrm>
+            <a:off x="557784" y="6463640"/>
+            <a:ext cx="1370293" cy="3383280"/>
+          </a:xfrm>
+          <a:prstGeom prst="rect">
+            <a:avLst/>
+          </a:prstGeom>
+          <a:noFill/>
+        </p:spPr>
+        <p:txBody>
+          <a:bodyPr wrap="square">
+            <a:spAutoFit/>
+          </a:bodyPr>
+          <a:lstStyle/>
+          <a:p>
+            <a:pPr algn="ctr"/>
+            <a:r>
+              <a:rPr b="0" sz="900">
+                <a:solidFill>
+                  <a:srgbClr val="C9D1D9"/>
+                </a:solidFill>
+              </a:rPr>
+              <a:t>Wire search_all_news + search_robotics_news into the agent so the chatbot reads from the same DB the pages scrape</a:t>
             </a:r>
           </a:p>
         </p:txBody>

</xml_diff>